<commit_message>
Maiden Astraea | Remove data transport chapter from theory since it is going to be described a lot with examples in practical part of thesis (as well as the fact that ESP-NOW has already been explained; Finalize theoretical part of thesis (content-wise); Add diagrams and images to visualize
</commit_message>
<xml_diff>
--- a/Diplomarbeit/doc/Schaar/Computermaus-Erklärung-Drehstab.pptx
+++ b/Diplomarbeit/doc/Schaar/Computermaus-Erklärung-Drehstab.pptx
@@ -197,7 +197,7 @@
           <a:p>
             <a:fld id="{EF4929A9-E944-459A-A902-19A3AFC66D15}" type="datetimeFigureOut">
               <a:rPr lang="de-AT" smtClean="0"/>
-              <a:t>21.02.2026</a:t>
+              <a:t>22.02.2026</a:t>
             </a:fld>
             <a:endParaRPr lang="de-AT"/>
           </a:p>
@@ -698,7 +698,7 @@
           <a:p>
             <a:fld id="{DF454D19-1CBA-428A-9FFC-0CBF0660AB44}" type="datetimeFigureOut">
               <a:rPr lang="de-AT" smtClean="0"/>
-              <a:t>21.02.2026</a:t>
+              <a:t>22.02.2026</a:t>
             </a:fld>
             <a:endParaRPr lang="de-AT"/>
           </a:p>
@@ -898,7 +898,7 @@
           <a:p>
             <a:fld id="{DF454D19-1CBA-428A-9FFC-0CBF0660AB44}" type="datetimeFigureOut">
               <a:rPr lang="de-AT" smtClean="0"/>
-              <a:t>21.02.2026</a:t>
+              <a:t>22.02.2026</a:t>
             </a:fld>
             <a:endParaRPr lang="de-AT"/>
           </a:p>
@@ -1108,7 +1108,7 @@
           <a:p>
             <a:fld id="{DF454D19-1CBA-428A-9FFC-0CBF0660AB44}" type="datetimeFigureOut">
               <a:rPr lang="de-AT" smtClean="0"/>
-              <a:t>21.02.2026</a:t>
+              <a:t>22.02.2026</a:t>
             </a:fld>
             <a:endParaRPr lang="de-AT"/>
           </a:p>
@@ -1308,7 +1308,7 @@
           <a:p>
             <a:fld id="{DF454D19-1CBA-428A-9FFC-0CBF0660AB44}" type="datetimeFigureOut">
               <a:rPr lang="de-AT" smtClean="0"/>
-              <a:t>21.02.2026</a:t>
+              <a:t>22.02.2026</a:t>
             </a:fld>
             <a:endParaRPr lang="de-AT"/>
           </a:p>
@@ -1584,7 +1584,7 @@
           <a:p>
             <a:fld id="{DF454D19-1CBA-428A-9FFC-0CBF0660AB44}" type="datetimeFigureOut">
               <a:rPr lang="de-AT" smtClean="0"/>
-              <a:t>21.02.2026</a:t>
+              <a:t>22.02.2026</a:t>
             </a:fld>
             <a:endParaRPr lang="de-AT"/>
           </a:p>
@@ -1852,7 +1852,7 @@
           <a:p>
             <a:fld id="{DF454D19-1CBA-428A-9FFC-0CBF0660AB44}" type="datetimeFigureOut">
               <a:rPr lang="de-AT" smtClean="0"/>
-              <a:t>21.02.2026</a:t>
+              <a:t>22.02.2026</a:t>
             </a:fld>
             <a:endParaRPr lang="de-AT"/>
           </a:p>
@@ -2267,7 +2267,7 @@
           <a:p>
             <a:fld id="{DF454D19-1CBA-428A-9FFC-0CBF0660AB44}" type="datetimeFigureOut">
               <a:rPr lang="de-AT" smtClean="0"/>
-              <a:t>21.02.2026</a:t>
+              <a:t>22.02.2026</a:t>
             </a:fld>
             <a:endParaRPr lang="de-AT"/>
           </a:p>
@@ -2409,7 +2409,7 @@
           <a:p>
             <a:fld id="{DF454D19-1CBA-428A-9FFC-0CBF0660AB44}" type="datetimeFigureOut">
               <a:rPr lang="de-AT" smtClean="0"/>
-              <a:t>21.02.2026</a:t>
+              <a:t>22.02.2026</a:t>
             </a:fld>
             <a:endParaRPr lang="de-AT"/>
           </a:p>
@@ -2522,7 +2522,7 @@
           <a:p>
             <a:fld id="{DF454D19-1CBA-428A-9FFC-0CBF0660AB44}" type="datetimeFigureOut">
               <a:rPr lang="de-AT" smtClean="0"/>
-              <a:t>21.02.2026</a:t>
+              <a:t>22.02.2026</a:t>
             </a:fld>
             <a:endParaRPr lang="de-AT"/>
           </a:p>
@@ -2835,7 +2835,7 @@
           <a:p>
             <a:fld id="{DF454D19-1CBA-428A-9FFC-0CBF0660AB44}" type="datetimeFigureOut">
               <a:rPr lang="de-AT" smtClean="0"/>
-              <a:t>21.02.2026</a:t>
+              <a:t>22.02.2026</a:t>
             </a:fld>
             <a:endParaRPr lang="de-AT"/>
           </a:p>
@@ -3124,7 +3124,7 @@
           <a:p>
             <a:fld id="{DF454D19-1CBA-428A-9FFC-0CBF0660AB44}" type="datetimeFigureOut">
               <a:rPr lang="de-AT" smtClean="0"/>
-              <a:t>21.02.2026</a:t>
+              <a:t>22.02.2026</a:t>
             </a:fld>
             <a:endParaRPr lang="de-AT"/>
           </a:p>
@@ -3367,7 +3367,7 @@
           <a:p>
             <a:fld id="{DF454D19-1CBA-428A-9FFC-0CBF0660AB44}" type="datetimeFigureOut">
               <a:rPr lang="de-AT" smtClean="0"/>
-              <a:t>21.02.2026</a:t>
+              <a:t>22.02.2026</a:t>
             </a:fld>
             <a:endParaRPr lang="de-AT"/>
           </a:p>
@@ -4562,6 +4562,321 @@
             <a:ext cx="1139056" cy="935915"/>
           </a:xfrm>
           <a:prstGeom prst="rightArrow">
+            <a:avLst/>
+          </a:prstGeom>
+        </p:spPr>
+        <p:style>
+          <a:lnRef idx="2">
+            <a:schemeClr val="accent1">
+              <a:shade val="15000"/>
+            </a:schemeClr>
+          </a:lnRef>
+          <a:fillRef idx="1">
+            <a:schemeClr val="accent1"/>
+          </a:fillRef>
+          <a:effectRef idx="0">
+            <a:schemeClr val="accent1"/>
+          </a:effectRef>
+          <a:fontRef idx="minor">
+            <a:schemeClr val="lt1"/>
+          </a:fontRef>
+        </p:style>
+        <p:txBody>
+          <a:bodyPr rtlCol="0" anchor="ctr"/>
+          <a:lstStyle/>
+          <a:p>
+            <a:pPr algn="ctr"/>
+            <a:endParaRPr lang="de-AT"/>
+          </a:p>
+        </p:txBody>
+      </p:sp>
+      <p:sp>
+        <p:nvSpPr>
+          <p:cNvPr id="3" name="Pfeil: nach links gekrümmt 2">
+            <a:extLst>
+              <a:ext uri="{FF2B5EF4-FFF2-40B4-BE49-F238E27FC236}">
+                <a16:creationId xmlns:a16="http://schemas.microsoft.com/office/drawing/2014/main" id="{C028D039-D6A7-9868-5AD4-FC89BFC1D234}"/>
+              </a:ext>
+            </a:extLst>
+          </p:cNvPr>
+          <p:cNvSpPr/>
+          <p:nvPr/>
+        </p:nvSpPr>
+        <p:spPr>
+          <a:xfrm>
+            <a:off x="6904778" y="4689468"/>
+            <a:ext cx="877146" cy="1114425"/>
+          </a:xfrm>
+          <a:prstGeom prst="curvedLeftArrow">
+            <a:avLst/>
+          </a:prstGeom>
+        </p:spPr>
+        <p:style>
+          <a:lnRef idx="2">
+            <a:schemeClr val="accent1">
+              <a:shade val="15000"/>
+            </a:schemeClr>
+          </a:lnRef>
+          <a:fillRef idx="1">
+            <a:schemeClr val="accent1"/>
+          </a:fillRef>
+          <a:effectRef idx="0">
+            <a:schemeClr val="accent1"/>
+          </a:effectRef>
+          <a:fontRef idx="minor">
+            <a:schemeClr val="lt1"/>
+          </a:fontRef>
+        </p:style>
+        <p:txBody>
+          <a:bodyPr rtlCol="0" anchor="ctr"/>
+          <a:lstStyle/>
+          <a:p>
+            <a:pPr algn="ctr"/>
+            <a:endParaRPr lang="de-AT">
+              <a:solidFill>
+                <a:schemeClr val="tx1"/>
+              </a:solidFill>
+            </a:endParaRPr>
+          </a:p>
+        </p:txBody>
+      </p:sp>
+      <p:sp>
+        <p:nvSpPr>
+          <p:cNvPr id="5" name="Pfeil: nach links gekrümmt 4">
+            <a:extLst>
+              <a:ext uri="{FF2B5EF4-FFF2-40B4-BE49-F238E27FC236}">
+                <a16:creationId xmlns:a16="http://schemas.microsoft.com/office/drawing/2014/main" id="{B5B0F2B0-3B4A-1BE8-1778-21BF398A78DC}"/>
+              </a:ext>
+            </a:extLst>
+          </p:cNvPr>
+          <p:cNvSpPr/>
+          <p:nvPr/>
+        </p:nvSpPr>
+        <p:spPr>
+          <a:xfrm flipH="1">
+            <a:off x="10428351" y="4689469"/>
+            <a:ext cx="877146" cy="1114425"/>
+          </a:xfrm>
+          <a:prstGeom prst="curvedLeftArrow">
+            <a:avLst/>
+          </a:prstGeom>
+        </p:spPr>
+        <p:style>
+          <a:lnRef idx="2">
+            <a:schemeClr val="accent1">
+              <a:shade val="15000"/>
+            </a:schemeClr>
+          </a:lnRef>
+          <a:fillRef idx="1">
+            <a:schemeClr val="accent1"/>
+          </a:fillRef>
+          <a:effectRef idx="0">
+            <a:schemeClr val="accent1"/>
+          </a:effectRef>
+          <a:fontRef idx="minor">
+            <a:schemeClr val="lt1"/>
+          </a:fontRef>
+        </p:style>
+        <p:txBody>
+          <a:bodyPr rtlCol="0" anchor="ctr"/>
+          <a:lstStyle/>
+          <a:p>
+            <a:pPr algn="ctr"/>
+            <a:endParaRPr lang="de-AT">
+              <a:solidFill>
+                <a:schemeClr val="tx1"/>
+              </a:solidFill>
+            </a:endParaRPr>
+          </a:p>
+        </p:txBody>
+      </p:sp>
+      <p:sp>
+        <p:nvSpPr>
+          <p:cNvPr id="10" name="Pfeil: nach links und rechts 9">
+            <a:extLst>
+              <a:ext uri="{FF2B5EF4-FFF2-40B4-BE49-F238E27FC236}">
+                <a16:creationId xmlns:a16="http://schemas.microsoft.com/office/drawing/2014/main" id="{FA67AFD4-1B3C-8278-CBBA-F5FB1F33B730}"/>
+              </a:ext>
+            </a:extLst>
+          </p:cNvPr>
+          <p:cNvSpPr/>
+          <p:nvPr/>
+        </p:nvSpPr>
+        <p:spPr>
+          <a:xfrm>
+            <a:off x="8039741" y="5100938"/>
+            <a:ext cx="2124519" cy="291484"/>
+          </a:xfrm>
+          <a:prstGeom prst="leftRightArrow">
+            <a:avLst/>
+          </a:prstGeom>
+          <a:ln>
+            <a:prstDash val="solid"/>
+          </a:ln>
+        </p:spPr>
+        <p:style>
+          <a:lnRef idx="2">
+            <a:schemeClr val="accent1">
+              <a:shade val="15000"/>
+            </a:schemeClr>
+          </a:lnRef>
+          <a:fillRef idx="1">
+            <a:schemeClr val="accent1"/>
+          </a:fillRef>
+          <a:effectRef idx="0">
+            <a:schemeClr val="accent1"/>
+          </a:effectRef>
+          <a:fontRef idx="minor">
+            <a:schemeClr val="lt1"/>
+          </a:fontRef>
+        </p:style>
+        <p:txBody>
+          <a:bodyPr rtlCol="0" anchor="ctr"/>
+          <a:lstStyle/>
+          <a:p>
+            <a:pPr algn="ctr"/>
+            <a:endParaRPr lang="de-AT"/>
+          </a:p>
+        </p:txBody>
+      </p:sp>
+      <p:sp>
+        <p:nvSpPr>
+          <p:cNvPr id="11" name="Textfeld 10">
+            <a:extLst>
+              <a:ext uri="{FF2B5EF4-FFF2-40B4-BE49-F238E27FC236}">
+                <a16:creationId xmlns:a16="http://schemas.microsoft.com/office/drawing/2014/main" id="{9963D915-7629-1C56-4784-79812F9614A5}"/>
+              </a:ext>
+            </a:extLst>
+          </p:cNvPr>
+          <p:cNvSpPr txBox="1"/>
+          <p:nvPr/>
+        </p:nvSpPr>
+        <p:spPr>
+          <a:xfrm>
+            <a:off x="8039742" y="5332744"/>
+            <a:ext cx="2124518" cy="338554"/>
+          </a:xfrm>
+          <a:prstGeom prst="rect">
+            <a:avLst/>
+          </a:prstGeom>
+          <a:noFill/>
+        </p:spPr>
+        <p:txBody>
+          <a:bodyPr wrap="square" rtlCol="0">
+            <a:spAutoFit/>
+          </a:bodyPr>
+          <a:lstStyle/>
+          <a:p>
+            <a:pPr algn="ctr"/>
+            <a:r>
+              <a:rPr lang="de-DE" sz="1600" b="1" dirty="0"/>
+              <a:t>Drehrichtung</a:t>
+            </a:r>
+            <a:endParaRPr lang="de-AT" sz="1600" b="1" dirty="0"/>
+          </a:p>
+        </p:txBody>
+      </p:sp>
+      <p:sp>
+        <p:nvSpPr>
+          <p:cNvPr id="14" name="Pfeil: nach oben 13">
+            <a:extLst>
+              <a:ext uri="{FF2B5EF4-FFF2-40B4-BE49-F238E27FC236}">
+                <a16:creationId xmlns:a16="http://schemas.microsoft.com/office/drawing/2014/main" id="{211A3B49-33D3-C46E-EDD7-86C7BCBB7F83}"/>
+              </a:ext>
+            </a:extLst>
+          </p:cNvPr>
+          <p:cNvSpPr/>
+          <p:nvPr/>
+        </p:nvSpPr>
+        <p:spPr>
+          <a:xfrm>
+            <a:off x="8905550" y="4173855"/>
+            <a:ext cx="392894" cy="395420"/>
+          </a:xfrm>
+          <a:prstGeom prst="upArrow">
+            <a:avLst/>
+          </a:prstGeom>
+        </p:spPr>
+        <p:style>
+          <a:lnRef idx="2">
+            <a:schemeClr val="accent1">
+              <a:shade val="15000"/>
+            </a:schemeClr>
+          </a:lnRef>
+          <a:fillRef idx="1">
+            <a:schemeClr val="accent1"/>
+          </a:fillRef>
+          <a:effectRef idx="0">
+            <a:schemeClr val="accent1"/>
+          </a:effectRef>
+          <a:fontRef idx="minor">
+            <a:schemeClr val="lt1"/>
+          </a:fontRef>
+        </p:style>
+        <p:txBody>
+          <a:bodyPr rtlCol="0" anchor="ctr"/>
+          <a:lstStyle/>
+          <a:p>
+            <a:pPr algn="ctr"/>
+            <a:endParaRPr lang="de-AT"/>
+          </a:p>
+        </p:txBody>
+      </p:sp>
+      <p:sp>
+        <p:nvSpPr>
+          <p:cNvPr id="15" name="Textfeld 14">
+            <a:extLst>
+              <a:ext uri="{FF2B5EF4-FFF2-40B4-BE49-F238E27FC236}">
+                <a16:creationId xmlns:a16="http://schemas.microsoft.com/office/drawing/2014/main" id="{84101DC1-BB77-C545-047C-A4AC1430F1EF}"/>
+              </a:ext>
+            </a:extLst>
+          </p:cNvPr>
+          <p:cNvSpPr txBox="1"/>
+          <p:nvPr/>
+        </p:nvSpPr>
+        <p:spPr>
+          <a:xfrm>
+            <a:off x="8039742" y="4605295"/>
+            <a:ext cx="2124518" cy="338554"/>
+          </a:xfrm>
+          <a:prstGeom prst="rect">
+            <a:avLst/>
+          </a:prstGeom>
+          <a:noFill/>
+        </p:spPr>
+        <p:txBody>
+          <a:bodyPr wrap="square" rtlCol="0">
+            <a:spAutoFit/>
+          </a:bodyPr>
+          <a:lstStyle/>
+          <a:p>
+            <a:pPr algn="ctr"/>
+            <a:r>
+              <a:rPr lang="de-DE" sz="1600" b="1" dirty="0"/>
+              <a:t>Drehstab</a:t>
+            </a:r>
+            <a:endParaRPr lang="de-AT" sz="1600" b="1" dirty="0"/>
+          </a:p>
+        </p:txBody>
+      </p:sp>
+      <p:sp>
+        <p:nvSpPr>
+          <p:cNvPr id="18" name="Rechteck: abgerundete Ecken 17">
+            <a:extLst>
+              <a:ext uri="{FF2B5EF4-FFF2-40B4-BE49-F238E27FC236}">
+                <a16:creationId xmlns:a16="http://schemas.microsoft.com/office/drawing/2014/main" id="{06943E3D-ED05-6163-B34A-ED0E19F2780C}"/>
+              </a:ext>
+            </a:extLst>
+          </p:cNvPr>
+          <p:cNvSpPr/>
+          <p:nvPr/>
+        </p:nvSpPr>
+        <p:spPr>
+          <a:xfrm>
+            <a:off x="2787810" y="2536395"/>
+            <a:ext cx="279676" cy="462794"/>
+          </a:xfrm>
+          <a:prstGeom prst="roundRect">
             <a:avLst/>
           </a:prstGeom>
         </p:spPr>

</xml_diff>